<commit_message>
Clean work sample repository
</commit_message>
<xml_diff>
--- a/doublespeak_experiment_slides.pptx
+++ b/doublespeak_experiment_slides.pptx
@@ -2,15 +2,15 @@
 <file path=ppt/presentation.xml><?xml version="1.0" encoding="utf-8"?>
 <p:presentation xmlns:p="http://schemas.openxmlformats.org/presentationml/2006/main">
   <p:sldMasterIdLst>
-    <p:sldMasterId xmlns:r="http://schemas.openxmlformats.org/officeDocument/2006/relationships" id="2147483648" r:id="R127eebe0ee4d4899"/>
+    <p:sldMasterId xmlns:r="http://schemas.openxmlformats.org/officeDocument/2006/relationships" id="2147483648" r:id="R2c099da30dc34ca2"/>
   </p:sldMasterIdLst>
   <p:notesMasterIdLst>
-    <p:notesMasterId xmlns:r="http://schemas.openxmlformats.org/officeDocument/2006/relationships" r:id="Raed3898d16934c6b"/>
+    <p:notesMasterId xmlns:r="http://schemas.openxmlformats.org/officeDocument/2006/relationships" r:id="R1420010812504005"/>
   </p:notesMasterIdLst>
   <p:sldIdLst>
-    <p:sldId xmlns:r="http://schemas.openxmlformats.org/officeDocument/2006/relationships" id="256" r:id="R9427fa256e6f40cc"/>
-    <p:sldId xmlns:r="http://schemas.openxmlformats.org/officeDocument/2006/relationships" id="257" r:id="R23b699c1477a4844"/>
-    <p:sldId xmlns:r="http://schemas.openxmlformats.org/officeDocument/2006/relationships" id="258" r:id="R878aca64524f477f"/>
+    <p:sldId xmlns:r="http://schemas.openxmlformats.org/officeDocument/2006/relationships" id="256" r:id="Rbdbfaead930647b5"/>
+    <p:sldId xmlns:r="http://schemas.openxmlformats.org/officeDocument/2006/relationships" id="257" r:id="R41819d38f09843bb"/>
+    <p:sldId xmlns:r="http://schemas.openxmlformats.org/officeDocument/2006/relationships" id="258" r:id="R8ca7ff50fa544101"/>
   </p:sldIdLst>
   <p:sldSz cx="12192000" cy="6858000"/>
   <p:notesSz cx="6858000" cy="9144000"/>
@@ -735,7 +735,7 @@
   </p:cSld>
   <p:clrMap bg1="lt1" tx1="dk1" bg2="lt2" tx2="dk2" accent1="accent1" accent2="accent2" accent3="accent3" accent4="accent4" accent5="accent5" accent6="accent6" hlink="hlink" folHlink="folHlink"/>
   <p:sldLayoutIdLst>
-    <p:sldLayoutId xmlns:r="http://schemas.openxmlformats.org/officeDocument/2006/relationships" id="2147483649" r:id="Rc11ba9feebd749af"/>
+    <p:sldLayoutId xmlns:r="http://schemas.openxmlformats.org/officeDocument/2006/relationships" id="2147483649" r:id="R81c899342359427f"/>
   </p:sldLayoutIdLst>
   <p:txStyles>
     <p:titleStyle>
@@ -1286,7 +1286,7 @@
           <p:cNvPr id="7" name="accent-rule">
             <a:extLst xmlns:a="http://schemas.openxmlformats.org/drawingml/2006/main">
               <a:ext uri="{FF2B5EF4-FFF2-40B4-BE49-F238E27FC236}">
-                <a16:creationId xmlns:a16="http://schemas.microsoft.com/office/drawing/2014/main" id="{F131AAD3-68D6-43BF-A12D-13A7CFC85500}"/>
+                <a16:creationId xmlns:a16="http://schemas.microsoft.com/office/drawing/2014/main" id="{F17D30D1-67C2-43DB-882C-71BBA42410EA}"/>
               </a:ext>
             </a:extLst>
           </p:cNvPr>
@@ -1317,7 +1317,7 @@
           <p:cNvPr id="2" name="eyebrow">
             <a:extLst xmlns:a="http://schemas.openxmlformats.org/drawingml/2006/main">
               <a:ext uri="{FF2B5EF4-FFF2-40B4-BE49-F238E27FC236}">
-                <a16:creationId xmlns:a16="http://schemas.microsoft.com/office/drawing/2014/main" id="{E71C3421-04F0-4A46-BC28-F12D8C1285D5}"/>
+                <a16:creationId xmlns:a16="http://schemas.microsoft.com/office/drawing/2014/main" id="{28511F52-1C95-4667-A7A3-1AE4774099C1}"/>
               </a:ext>
             </a:extLst>
           </p:cNvPr>
@@ -1362,7 +1362,7 @@
           <p:cNvPr id="3" name="main-question">
             <a:extLst xmlns:a="http://schemas.openxmlformats.org/drawingml/2006/main">
               <a:ext uri="{FF2B5EF4-FFF2-40B4-BE49-F238E27FC236}">
-                <a16:creationId xmlns:a16="http://schemas.microsoft.com/office/drawing/2014/main" id="{2101D78A-F336-450B-B70F-A27DE62E13C6}"/>
+                <a16:creationId xmlns:a16="http://schemas.microsoft.com/office/drawing/2014/main" id="{326571F1-F123-40B6-ADEA-CCFC57F8F90B}"/>
               </a:ext>
             </a:extLst>
           </p:cNvPr>
@@ -1408,7 +1408,7 @@
           <p:cNvPr id="4" name="scope">
             <a:extLst xmlns:a="http://schemas.openxmlformats.org/drawingml/2006/main">
               <a:ext uri="{FF2B5EF4-FFF2-40B4-BE49-F238E27FC236}">
-                <a16:creationId xmlns:a16="http://schemas.microsoft.com/office/drawing/2014/main" id="{60018EE7-FEA7-4859-B097-D0B9AA5F4966}"/>
+                <a16:creationId xmlns:a16="http://schemas.microsoft.com/office/drawing/2014/main" id="{5E487870-CF29-404C-8E97-27591E4BB933}"/>
               </a:ext>
             </a:extLst>
           </p:cNvPr>
@@ -1453,7 +1453,7 @@
           <p:cNvPr id="5" name="definition">
             <a:extLst xmlns:a="http://schemas.openxmlformats.org/drawingml/2006/main">
               <a:ext uri="{FF2B5EF4-FFF2-40B4-BE49-F238E27FC236}">
-                <a16:creationId xmlns:a16="http://schemas.microsoft.com/office/drawing/2014/main" id="{9300350C-1CA9-48A1-B79A-3291241118D5}"/>
+                <a16:creationId xmlns:a16="http://schemas.microsoft.com/office/drawing/2014/main" id="{010407EA-ECB4-4A29-867E-568E8FFAB255}"/>
               </a:ext>
             </a:extLst>
           </p:cNvPr>
@@ -1498,7 +1498,7 @@
           <p:cNvPr id="6" name="footer-1">
             <a:extLst xmlns:a="http://schemas.openxmlformats.org/drawingml/2006/main">
               <a:ext uri="{FF2B5EF4-FFF2-40B4-BE49-F238E27FC236}">
-                <a16:creationId xmlns:a16="http://schemas.microsoft.com/office/drawing/2014/main" id="{5687101E-3938-4605-AB4A-4887C9CB9516}"/>
+                <a16:creationId xmlns:a16="http://schemas.microsoft.com/office/drawing/2014/main" id="{91A3CDA0-81C6-4E30-AB7A-587C0CBE49D5}"/>
               </a:ext>
             </a:extLst>
           </p:cNvPr>
@@ -1539,7 +1539,7 @@
     </p:spTree>
     <p:extLst>
       <p:ext uri="{BB962C8B-B14F-4D97-AF65-F5344CB8AC3E}">
-        <p14:creationId xmlns:p14="http://schemas.microsoft.com/office/powerpoint/2010/main" val="1039182582"/>
+        <p14:creationId xmlns:p14="http://schemas.microsoft.com/office/powerpoint/2010/main" val="1119340129"/>
       </p:ext>
     </p:extLst>
   </p:cSld>
@@ -1570,7 +1570,7 @@
           <p:cNvPr id="16" name="method-title">
             <a:extLst xmlns:a="http://schemas.openxmlformats.org/drawingml/2006/main">
               <a:ext uri="{FF2B5EF4-FFF2-40B4-BE49-F238E27FC236}">
-                <a16:creationId xmlns:a16="http://schemas.microsoft.com/office/drawing/2014/main" id="{ADB7C557-D857-45B9-B62D-08DEE7DCA594}"/>
+                <a16:creationId xmlns:a16="http://schemas.microsoft.com/office/drawing/2014/main" id="{5065A7E2-4280-44BB-94FF-759E758EFB1F}"/>
               </a:ext>
             </a:extLst>
           </p:cNvPr>
@@ -1590,7 +1590,7 @@
         </p:spPr>
         <p:txBody>
           <a:bodyPr xmlns:a="http://schemas.openxmlformats.org/drawingml/2006/main" lIns="0" tIns="0" rIns="0" bIns="0">
-            <a:normAutofit fontScale="87076"/>
+            <a:normAutofit fontScale="100000"/>
           </a:bodyPr>
           <a:lstStyle xmlns:a="http://schemas.openxmlformats.org/drawingml/2006/main"/>
           <a:p xmlns:a="http://schemas.openxmlformats.org/drawingml/2006/main">
@@ -1605,7 +1605,7 @@
               </a:defRPr>
             </a:pPr>
             <a:r>
-              <a:t>Each example was tested twice—with no response sharing</a:t>
+              <a:t>Two fresh calls test each example independently</a:t>
             </a:r>
           </a:p>
         </p:txBody>
@@ -1615,7 +1615,7 @@
           <p:cNvPr id="2" name="method-subtitle">
             <a:extLst xmlns:a="http://schemas.openxmlformats.org/drawingml/2006/main">
               <a:ext uri="{FF2B5EF4-FFF2-40B4-BE49-F238E27FC236}">
-                <a16:creationId xmlns:a16="http://schemas.microsoft.com/office/drawing/2014/main" id="{F71200B4-5931-4D00-8975-1E58E4EE1856}"/>
+                <a16:creationId xmlns:a16="http://schemas.microsoft.com/office/drawing/2014/main" id="{4DE89F8C-15C5-4B2A-A9D9-AE5BFC89D9B0}"/>
               </a:ext>
             </a:extLst>
           </p:cNvPr>
@@ -1680,7 +1680,7 @@
           <p:cNvPr id="4" name="node-1">
             <a:extLst xmlns:a="http://schemas.openxmlformats.org/drawingml/2006/main">
               <a:ext uri="{FF2B5EF4-FFF2-40B4-BE49-F238E27FC236}">
-                <a16:creationId xmlns:a16="http://schemas.microsoft.com/office/drawing/2014/main" id="{50579076-418E-49F3-A447-46E146F15E02}"/>
+                <a16:creationId xmlns:a16="http://schemas.microsoft.com/office/drawing/2014/main" id="{3D7FA586-084C-44D5-AA94-B61B5133AF63}"/>
               </a:ext>
             </a:extLst>
           </p:cNvPr>
@@ -1711,7 +1711,7 @@
           <p:cNvPr id="5" name="node-2">
             <a:extLst xmlns:a="http://schemas.openxmlformats.org/drawingml/2006/main">
               <a:ext uri="{FF2B5EF4-FFF2-40B4-BE49-F238E27FC236}">
-                <a16:creationId xmlns:a16="http://schemas.microsoft.com/office/drawing/2014/main" id="{3569B87A-5F97-4F05-AB60-776D4292EA5D}"/>
+                <a16:creationId xmlns:a16="http://schemas.microsoft.com/office/drawing/2014/main" id="{7C9EF24F-CD3E-45DE-862B-B9001F5F72A0}"/>
               </a:ext>
             </a:extLst>
           </p:cNvPr>
@@ -1742,7 +1742,7 @@
           <p:cNvPr id="6" name="node-3">
             <a:extLst xmlns:a="http://schemas.openxmlformats.org/drawingml/2006/main">
               <a:ext uri="{FF2B5EF4-FFF2-40B4-BE49-F238E27FC236}">
-                <a16:creationId xmlns:a16="http://schemas.microsoft.com/office/drawing/2014/main" id="{318E16E0-1845-421A-821B-E74492671924}"/>
+                <a16:creationId xmlns:a16="http://schemas.microsoft.com/office/drawing/2014/main" id="{176681CD-725D-4580-8BA6-CD625659218B}"/>
               </a:ext>
             </a:extLst>
           </p:cNvPr>
@@ -1773,7 +1773,7 @@
           <p:cNvPr id="7" name="label-1">
             <a:extLst xmlns:a="http://schemas.openxmlformats.org/drawingml/2006/main">
               <a:ext uri="{FF2B5EF4-FFF2-40B4-BE49-F238E27FC236}">
-                <a16:creationId xmlns:a16="http://schemas.microsoft.com/office/drawing/2014/main" id="{2438E0E9-E34A-4F98-842F-1662B0E5FF28}"/>
+                <a16:creationId xmlns:a16="http://schemas.microsoft.com/office/drawing/2014/main" id="{25DB33FE-6C73-4B1D-A06A-C344AEF0C61D}"/>
               </a:ext>
             </a:extLst>
           </p:cNvPr>
@@ -1816,7 +1816,7 @@
           <p:cNvPr id="8" name="label-2">
             <a:extLst xmlns:a="http://schemas.openxmlformats.org/drawingml/2006/main">
               <a:ext uri="{FF2B5EF4-FFF2-40B4-BE49-F238E27FC236}">
-                <a16:creationId xmlns:a16="http://schemas.microsoft.com/office/drawing/2014/main" id="{32DF18A8-573D-458D-A8EC-2FFB9A920951}"/>
+                <a16:creationId xmlns:a16="http://schemas.microsoft.com/office/drawing/2014/main" id="{C7374A35-67EB-4F40-8961-0519C1D38355}"/>
               </a:ext>
             </a:extLst>
           </p:cNvPr>
@@ -1859,7 +1859,7 @@
           <p:cNvPr id="9" name="label-3">
             <a:extLst xmlns:a="http://schemas.openxmlformats.org/drawingml/2006/main">
               <a:ext uri="{FF2B5EF4-FFF2-40B4-BE49-F238E27FC236}">
-                <a16:creationId xmlns:a16="http://schemas.microsoft.com/office/drawing/2014/main" id="{3C6F5D14-779A-4F13-ACC2-40DCA1FFF361}"/>
+                <a16:creationId xmlns:a16="http://schemas.microsoft.com/office/drawing/2014/main" id="{A72AC361-2BC8-4929-8D45-ECB7CE36C697}"/>
               </a:ext>
             </a:extLst>
           </p:cNvPr>
@@ -1902,7 +1902,7 @@
           <p:cNvPr id="10" name="step-1">
             <a:extLst xmlns:a="http://schemas.openxmlformats.org/drawingml/2006/main">
               <a:ext uri="{FF2B5EF4-FFF2-40B4-BE49-F238E27FC236}">
-                <a16:creationId xmlns:a16="http://schemas.microsoft.com/office/drawing/2014/main" id="{674CB0B5-50AB-4983-BD4B-86F9A7EB463D}"/>
+                <a16:creationId xmlns:a16="http://schemas.microsoft.com/office/drawing/2014/main" id="{0E7AE268-8FEE-4429-9384-BC78B42D20FB}"/>
               </a:ext>
             </a:extLst>
           </p:cNvPr>
@@ -1948,7 +1948,7 @@
           <p:cNvPr id="11" name="step-2">
             <a:extLst xmlns:a="http://schemas.openxmlformats.org/drawingml/2006/main">
               <a:ext uri="{FF2B5EF4-FFF2-40B4-BE49-F238E27FC236}">
-                <a16:creationId xmlns:a16="http://schemas.microsoft.com/office/drawing/2014/main" id="{FECA577C-6F44-42D6-98A8-663DCE3D0296}"/>
+                <a16:creationId xmlns:a16="http://schemas.microsoft.com/office/drawing/2014/main" id="{C2E13AF0-0E58-4451-B5BF-BDA094FD9F2C}"/>
               </a:ext>
             </a:extLst>
           </p:cNvPr>
@@ -1994,7 +1994,7 @@
           <p:cNvPr id="12" name="step-3">
             <a:extLst xmlns:a="http://schemas.openxmlformats.org/drawingml/2006/main">
               <a:ext uri="{FF2B5EF4-FFF2-40B4-BE49-F238E27FC236}">
-                <a16:creationId xmlns:a16="http://schemas.microsoft.com/office/drawing/2014/main" id="{E93DF072-62AF-4745-9724-7D2B3A851B8C}"/>
+                <a16:creationId xmlns:a16="http://schemas.microsoft.com/office/drawing/2014/main" id="{ED6D8C8A-A62D-4D72-B2CB-117D574F17AD}"/>
               </a:ext>
             </a:extLst>
           </p:cNvPr>
@@ -2042,7 +2042,7 @@
           <p:cNvPr id="13" name="call-count-band">
             <a:extLst xmlns:a="http://schemas.openxmlformats.org/drawingml/2006/main">
               <a:ext uri="{FF2B5EF4-FFF2-40B4-BE49-F238E27FC236}">
-                <a16:creationId xmlns:a16="http://schemas.microsoft.com/office/drawing/2014/main" id="{64942119-618F-4B9C-8378-1BA2BC22824B}"/>
+                <a16:creationId xmlns:a16="http://schemas.microsoft.com/office/drawing/2014/main" id="{BDF85149-FD5E-4BEB-8CDA-83046164EDD6}"/>
               </a:ext>
             </a:extLst>
           </p:cNvPr>
@@ -2073,7 +2073,7 @@
           <p:cNvPr id="14" name="call-count">
             <a:extLst xmlns:a="http://schemas.openxmlformats.org/drawingml/2006/main">
               <a:ext uri="{FF2B5EF4-FFF2-40B4-BE49-F238E27FC236}">
-                <a16:creationId xmlns:a16="http://schemas.microsoft.com/office/drawing/2014/main" id="{134D4DC2-559C-4F5D-ACD9-314A27C87721}"/>
+                <a16:creationId xmlns:a16="http://schemas.microsoft.com/office/drawing/2014/main" id="{B34033A9-03E5-4FE1-9F64-60F3E5611C8D}"/>
               </a:ext>
             </a:extLst>
           </p:cNvPr>
@@ -2116,7 +2116,7 @@
           <p:cNvPr id="15" name="footer-2">
             <a:extLst xmlns:a="http://schemas.openxmlformats.org/drawingml/2006/main">
               <a:ext uri="{FF2B5EF4-FFF2-40B4-BE49-F238E27FC236}">
-                <a16:creationId xmlns:a16="http://schemas.microsoft.com/office/drawing/2014/main" id="{1B600467-D964-42D4-A911-F7CB6A0CA9A2}"/>
+                <a16:creationId xmlns:a16="http://schemas.microsoft.com/office/drawing/2014/main" id="{0A200734-CAE0-47E8-92A5-6CAD5723A1C1}"/>
               </a:ext>
             </a:extLst>
           </p:cNvPr>
@@ -2157,7 +2157,7 @@
     </p:spTree>
     <p:extLst>
       <p:ext uri="{BB962C8B-B14F-4D97-AF65-F5344CB8AC3E}">
-        <p14:creationId xmlns:p14="http://schemas.microsoft.com/office/powerpoint/2010/main" val="542494186"/>
+        <p14:creationId xmlns:p14="http://schemas.microsoft.com/office/powerpoint/2010/main" val="592414569"/>
       </p:ext>
     </p:extLst>
   </p:cSld>
@@ -2188,7 +2188,7 @@
           <p:cNvPr id="8" name="results-title">
             <a:extLst xmlns:a="http://schemas.openxmlformats.org/drawingml/2006/main">
               <a:ext uri="{FF2B5EF4-FFF2-40B4-BE49-F238E27FC236}">
-                <a16:creationId xmlns:a16="http://schemas.microsoft.com/office/drawing/2014/main" id="{881CF599-516C-4B7B-A6A3-1FD457C4B517}"/>
+                <a16:creationId xmlns:a16="http://schemas.microsoft.com/office/drawing/2014/main" id="{74DBBFAE-80AC-4B12-9AEB-CCF1D64F3A00}"/>
               </a:ext>
             </a:extLst>
           </p:cNvPr>
@@ -2233,7 +2233,7 @@
           <p:cNvPr id="2" name="results-subtitle">
             <a:extLst xmlns:a="http://schemas.openxmlformats.org/drawingml/2006/main">
               <a:ext uri="{FF2B5EF4-FFF2-40B4-BE49-F238E27FC236}">
-                <a16:creationId xmlns:a16="http://schemas.microsoft.com/office/drawing/2014/main" id="{4F30A2B1-6D4B-4FB0-ADE9-17E2DA42924D}"/>
+                <a16:creationId xmlns:a16="http://schemas.microsoft.com/office/drawing/2014/main" id="{BB51E016-A180-4FC9-BB60-25DAF57147E6}"/>
               </a:ext>
             </a:extLst>
           </p:cNvPr>
@@ -2623,7 +2623,7 @@
           <p:cNvPr id="4" name="interpretation-band">
             <a:extLst xmlns:a="http://schemas.openxmlformats.org/drawingml/2006/main">
               <a:ext uri="{FF2B5EF4-FFF2-40B4-BE49-F238E27FC236}">
-                <a16:creationId xmlns:a16="http://schemas.microsoft.com/office/drawing/2014/main" id="{A17A6F82-994C-4106-B246-9CBD40A43382}"/>
+                <a16:creationId xmlns:a16="http://schemas.microsoft.com/office/drawing/2014/main" id="{D03BB0B9-6F07-40CE-9035-12F31FAFD5AF}"/>
               </a:ext>
             </a:extLst>
           </p:cNvPr>
@@ -2654,7 +2654,7 @@
           <p:cNvPr id="5" name="interpretation-label">
             <a:extLst xmlns:a="http://schemas.openxmlformats.org/drawingml/2006/main">
               <a:ext uri="{FF2B5EF4-FFF2-40B4-BE49-F238E27FC236}">
-                <a16:creationId xmlns:a16="http://schemas.microsoft.com/office/drawing/2014/main" id="{A1FAFEA4-BD52-4CC6-86F3-D3374A53D3B8}"/>
+                <a16:creationId xmlns:a16="http://schemas.microsoft.com/office/drawing/2014/main" id="{D46AC494-F048-4B75-AE32-330A1E813C45}"/>
               </a:ext>
             </a:extLst>
           </p:cNvPr>
@@ -2697,7 +2697,7 @@
           <p:cNvPr id="6" name="interpretation-copy">
             <a:extLst xmlns:a="http://schemas.openxmlformats.org/drawingml/2006/main">
               <a:ext uri="{FF2B5EF4-FFF2-40B4-BE49-F238E27FC236}">
-                <a16:creationId xmlns:a16="http://schemas.microsoft.com/office/drawing/2014/main" id="{F569AB29-24AF-438D-B036-AE21AF4EA3F9}"/>
+                <a16:creationId xmlns:a16="http://schemas.microsoft.com/office/drawing/2014/main" id="{FB5D3E16-E238-4DEC-8FA6-094CE900710E}"/>
               </a:ext>
             </a:extLst>
           </p:cNvPr>
@@ -2742,7 +2742,7 @@
           <p:cNvPr id="7" name="footer-3">
             <a:extLst xmlns:a="http://schemas.openxmlformats.org/drawingml/2006/main">
               <a:ext uri="{FF2B5EF4-FFF2-40B4-BE49-F238E27FC236}">
-                <a16:creationId xmlns:a16="http://schemas.microsoft.com/office/drawing/2014/main" id="{7FF194F7-BB99-4643-93BC-04ABBC4079E3}"/>
+                <a16:creationId xmlns:a16="http://schemas.microsoft.com/office/drawing/2014/main" id="{5941ADFE-16C1-4902-8067-DEE71C5BC98C}"/>
               </a:ext>
             </a:extLst>
           </p:cNvPr>
@@ -2783,7 +2783,7 @@
     </p:spTree>
     <p:extLst>
       <p:ext uri="{BB962C8B-B14F-4D97-AF65-F5344CB8AC3E}">
-        <p14:creationId xmlns:p14="http://schemas.microsoft.com/office/powerpoint/2010/main" val="455931916"/>
+        <p14:creationId xmlns:p14="http://schemas.microsoft.com/office/powerpoint/2010/main" val="384019694"/>
       </p:ext>
     </p:extLst>
   </p:cSld>

</xml_diff>